<commit_message>
changed figure ratio; presentation updated
</commit_message>
<xml_diff>
--- a/Presentation.pptx
+++ b/Presentation.pptx
@@ -116,6 +116,11 @@
       </a:defRPr>
     </a:lvl9pPr>
   </p:defaultTextStyle>
+  <p:extLst>
+    <p:ext uri="{EFAFB233-063F-42B5-8137-9DF3F51BA10A}">
+      <p15:sldGuideLst xmlns:p15="http://schemas.microsoft.com/office/powerpoint/2012/main"/>
+    </p:ext>
+  </p:extLst>
 </p:presentation>
 </file>
 
@@ -3442,7 +3447,7 @@
           <a:p>
             <a:fld id="{83AD7D89-F6F2-EB46-942D-37A2D9DCF75A}" type="datetimeFigureOut">
               <a:rPr lang="en-US" smtClean="0"/>
-              <a:t>3/3/26</a:t>
+              <a:t>3/4/26</a:t>
             </a:fld>
             <a:endParaRPr lang="en-US"/>
           </a:p>
@@ -4076,7 +4081,7 @@
           <a:p>
             <a:fld id="{E80C50CD-E178-4744-9B35-B2F624D6C5E9}" type="datetimeFigureOut">
               <a:rPr lang="en-US" smtClean="0"/>
-              <a:t>3/2/26</a:t>
+              <a:t>3/4/26</a:t>
             </a:fld>
             <a:endParaRPr lang="en-US"/>
           </a:p>
@@ -4274,7 +4279,7 @@
           <a:p>
             <a:fld id="{E80C50CD-E178-4744-9B35-B2F624D6C5E9}" type="datetimeFigureOut">
               <a:rPr lang="en-US" smtClean="0"/>
-              <a:t>3/2/26</a:t>
+              <a:t>3/4/26</a:t>
             </a:fld>
             <a:endParaRPr lang="en-US"/>
           </a:p>
@@ -4482,7 +4487,7 @@
           <a:p>
             <a:fld id="{E80C50CD-E178-4744-9B35-B2F624D6C5E9}" type="datetimeFigureOut">
               <a:rPr lang="en-US" smtClean="0"/>
-              <a:t>3/2/26</a:t>
+              <a:t>3/4/26</a:t>
             </a:fld>
             <a:endParaRPr lang="en-US"/>
           </a:p>
@@ -4732,7 +4737,7 @@
           <a:p>
             <a:fld id="{E80C50CD-E178-4744-9B35-B2F624D6C5E9}" type="datetimeFigureOut">
               <a:rPr lang="en-US" smtClean="0"/>
-              <a:t>3/2/26</a:t>
+              <a:t>3/4/26</a:t>
             </a:fld>
             <a:endParaRPr lang="en-US"/>
           </a:p>
@@ -5011,7 +5016,7 @@
           <a:p>
             <a:fld id="{E80C50CD-E178-4744-9B35-B2F624D6C5E9}" type="datetimeFigureOut">
               <a:rPr lang="en-US" smtClean="0"/>
-              <a:t>3/2/26</a:t>
+              <a:t>3/4/26</a:t>
             </a:fld>
             <a:endParaRPr lang="en-US"/>
           </a:p>
@@ -5328,7 +5333,7 @@
           <a:p>
             <a:fld id="{E80C50CD-E178-4744-9B35-B2F624D6C5E9}" type="datetimeFigureOut">
               <a:rPr lang="en-US" smtClean="0"/>
-              <a:t>3/2/26</a:t>
+              <a:t>3/4/26</a:t>
             </a:fld>
             <a:endParaRPr lang="en-US"/>
           </a:p>
@@ -5744,7 +5749,7 @@
           <a:p>
             <a:fld id="{E80C50CD-E178-4744-9B35-B2F624D6C5E9}" type="datetimeFigureOut">
               <a:rPr lang="en-US" smtClean="0"/>
-              <a:t>3/2/26</a:t>
+              <a:t>3/4/26</a:t>
             </a:fld>
             <a:endParaRPr lang="en-US"/>
           </a:p>
@@ -5885,7 +5890,7 @@
           <a:p>
             <a:fld id="{E80C50CD-E178-4744-9B35-B2F624D6C5E9}" type="datetimeFigureOut">
               <a:rPr lang="en-US" smtClean="0"/>
-              <a:t>3/2/26</a:t>
+              <a:t>3/4/26</a:t>
             </a:fld>
             <a:endParaRPr lang="en-US"/>
           </a:p>
@@ -5998,7 +6003,7 @@
           <a:p>
             <a:fld id="{E80C50CD-E178-4744-9B35-B2F624D6C5E9}" type="datetimeFigureOut">
               <a:rPr lang="en-US" smtClean="0"/>
-              <a:t>3/2/26</a:t>
+              <a:t>3/4/26</a:t>
             </a:fld>
             <a:endParaRPr lang="en-US"/>
           </a:p>
@@ -6315,7 +6320,7 @@
           <a:p>
             <a:fld id="{E80C50CD-E178-4744-9B35-B2F624D6C5E9}" type="datetimeFigureOut">
               <a:rPr lang="en-US" smtClean="0"/>
-              <a:t>3/2/26</a:t>
+              <a:t>3/4/26</a:t>
             </a:fld>
             <a:endParaRPr lang="en-US"/>
           </a:p>
@@ -6607,7 +6612,7 @@
           <a:p>
             <a:fld id="{E80C50CD-E178-4744-9B35-B2F624D6C5E9}" type="datetimeFigureOut">
               <a:rPr lang="en-US" smtClean="0"/>
-              <a:t>3/2/26</a:t>
+              <a:t>3/4/26</a:t>
             </a:fld>
             <a:endParaRPr lang="en-US"/>
           </a:p>
@@ -6847,7 +6852,7 @@
             <a:fld id="{E80C50CD-E178-4744-9B35-B2F624D6C5E9}" type="datetimeFigureOut">
               <a:rPr lang="en-US" smtClean="0"/>
               <a:pPr/>
-              <a:t>3/2/26</a:t>
+              <a:t>3/4/26</a:t>
             </a:fld>
             <a:endParaRPr lang="en-US"/>
           </a:p>
@@ -8384,8 +8389,8 @@
         </p:nvGrpSpPr>
         <p:grpSpPr>
           <a:xfrm>
-            <a:off x="786232" y="1972639"/>
-            <a:ext cx="5309768" cy="1424834"/>
+            <a:off x="786232" y="1972638"/>
+            <a:ext cx="5309768" cy="1727149"/>
             <a:chOff x="786232" y="1972639"/>
             <a:chExt cx="5309768" cy="1424834"/>
           </a:xfrm>
@@ -8511,8 +8516,8 @@
         </p:nvGrpSpPr>
         <p:grpSpPr>
           <a:xfrm>
-            <a:off x="786232" y="3717561"/>
-            <a:ext cx="10537959" cy="2623277"/>
+            <a:off x="786232" y="3878094"/>
+            <a:ext cx="10537959" cy="2462744"/>
             <a:chOff x="786232" y="1972639"/>
             <a:chExt cx="10537960" cy="1424834"/>
           </a:xfrm>
@@ -8639,7 +8644,7 @@
         <p:grpSpPr>
           <a:xfrm>
             <a:off x="6288046" y="1955320"/>
-            <a:ext cx="5036145" cy="1424834"/>
+            <a:ext cx="5036145" cy="1744468"/>
             <a:chOff x="786232" y="1972639"/>
             <a:chExt cx="5036145" cy="1424834"/>
           </a:xfrm>
@@ -8877,8 +8882,8 @@
         </p:nvSpPr>
         <p:spPr>
           <a:xfrm>
-            <a:off x="6711218" y="2067573"/>
-            <a:ext cx="3691956" cy="923330"/>
+            <a:off x="6711218" y="2000519"/>
+            <a:ext cx="4396493" cy="1477328"/>
           </a:xfrm>
           <a:prstGeom prst="rect">
             <a:avLst/>
@@ -8905,7 +8910,13 @@
           <a:p>
             <a:r>
               <a:rPr lang="en-US" dirty="0"/>
-              <a:t>15-min interval meter data (kWh)</a:t>
+              <a:t>15-min interval meter data (kWh), resampled to hourly kW.</a:t>
+            </a:r>
+          </a:p>
+          <a:p>
+            <a:r>
+              <a:rPr lang="en-US" dirty="0"/>
+              <a:t>Time-zone normalized to EDT</a:t>
             </a:r>
           </a:p>
         </p:txBody>
@@ -8963,7 +8974,7 @@
           <p:nvPr>
             <p:extLst>
               <p:ext uri="{D42A27DB-BD31-4B8C-83A1-F6EECF244321}">
-                <p14:modId xmlns:p14="http://schemas.microsoft.com/office/powerpoint/2010/main" val="1406061778"/>
+                <p14:modId xmlns:p14="http://schemas.microsoft.com/office/powerpoint/2010/main" val="2689613416"/>
               </p:ext>
             </p:extLst>
           </p:nvPr>
@@ -9190,7 +9201,7 @@
                             <a:schemeClr val="tx1"/>
                           </a:solidFill>
                         </a:rPr>
-                        <a:t>System benchmark</a:t>
+                        <a:t>Fixed system benchmark per site</a:t>
                       </a:r>
                     </a:p>
                   </a:txBody>
@@ -9339,7 +9350,7 @@
                             <a:schemeClr val="tx1"/>
                           </a:solidFill>
                         </a:rPr>
-                        <a:t>Based on MISO system peak conditions</a:t>
+                        <a:t>Based on MISO system peak conditions, independent of recent customer operations. </a:t>
                       </a:r>
                     </a:p>
                   </a:txBody>
@@ -9513,14 +9524,53 @@
         </p:blipFill>
         <p:spPr>
           <a:xfrm>
-            <a:off x="650822" y="1651483"/>
-            <a:ext cx="10889483" cy="4540165"/>
+            <a:off x="347116" y="1554281"/>
+            <a:ext cx="11497768" cy="4793778"/>
           </a:xfrm>
           <a:prstGeom prst="rect">
             <a:avLst/>
           </a:prstGeom>
         </p:spPr>
       </p:pic>
+      <p:sp>
+        <p:nvSpPr>
+          <p:cNvPr id="3" name="TextBox 2">
+            <a:extLst>
+              <a:ext uri="{FF2B5EF4-FFF2-40B4-BE49-F238E27FC236}">
+                <a16:creationId xmlns:a16="http://schemas.microsoft.com/office/drawing/2014/main" id="{C0F16835-43AB-EC6D-42AF-3564F5BA2C7E}"/>
+              </a:ext>
+            </a:extLst>
+          </p:cNvPr>
+          <p:cNvSpPr txBox="1"/>
+          <p:nvPr/>
+        </p:nvSpPr>
+        <p:spPr>
+          <a:xfrm>
+            <a:off x="9936570" y="5883872"/>
+            <a:ext cx="1737270" cy="307777"/>
+          </a:xfrm>
+          <a:prstGeom prst="rect">
+            <a:avLst/>
+          </a:prstGeom>
+          <a:noFill/>
+        </p:spPr>
+        <p:txBody>
+          <a:bodyPr wrap="none" rtlCol="0">
+            <a:spAutoFit/>
+          </a:bodyPr>
+          <a:lstStyle/>
+          <a:p>
+            <a:r>
+              <a:rPr lang="en-US" sz="1400" dirty="0">
+                <a:solidFill>
+                  <a:srgbClr val="4E1D1D"/>
+                </a:solidFill>
+              </a:rPr>
+              <a:t>* y-axis scales differ</a:t>
+            </a:r>
+          </a:p>
+        </p:txBody>
+      </p:sp>
     </p:spTree>
     <p:extLst>
       <p:ext uri="{BB962C8B-B14F-4D97-AF65-F5344CB8AC3E}">
@@ -9616,7 +9666,7 @@
                   <a:srgbClr val="4E1D1D"/>
                 </a:solidFill>
               </a:rPr>
-              <a:t>Building Type Inference</a:t>
+              <a:t>Building Type Hypothesis</a:t>
             </a:r>
           </a:p>
         </p:txBody>
@@ -9636,7 +9686,7 @@
           <p:nvPr>
             <p:extLst>
               <p:ext uri="{D42A27DB-BD31-4B8C-83A1-F6EECF244321}">
-                <p14:modId xmlns:p14="http://schemas.microsoft.com/office/powerpoint/2010/main" val="2427484523"/>
+                <p14:modId xmlns:p14="http://schemas.microsoft.com/office/powerpoint/2010/main" val="3384268829"/>
               </p:ext>
             </p:extLst>
           </p:nvPr>
@@ -10161,7 +10211,7 @@
                             <a:srgbClr val="4E1D1D"/>
                           </a:solidFill>
                         </a:rPr>
-                        <a:t>Mid-Sized Plants (M-F)</a:t>
+                        <a:t>Mid-Sized Manufacturing (M-F)</a:t>
                       </a:r>
                     </a:p>
                   </a:txBody>
@@ -10549,7 +10599,7 @@
                             <a:srgbClr val="4E1D1D"/>
                           </a:solidFill>
                         </a:rPr>
-                        <a:t>24/7 Commercial or hospital</a:t>
+                        <a:t>24/7 Continuous Load (e.g. mall, hospital)</a:t>
                       </a:r>
                     </a:p>
                   </a:txBody>
@@ -10752,7 +10802,7 @@
                             <a:srgbClr val="4E1D1D"/>
                           </a:solidFill>
                         </a:rPr>
-                        <a:t>Small business-hour building</a:t>
+                        <a:t>Mid-sized business-hour building</a:t>
                       </a:r>
                     </a:p>
                   </a:txBody>
@@ -10958,37 +11008,6 @@
           <a:chExt cx="0" cy="0"/>
         </a:xfrm>
       </p:grpSpPr>
-      <p:pic>
-        <p:nvPicPr>
-          <p:cNvPr id="7" name="Picture 6">
-            <a:extLst>
-              <a:ext uri="{FF2B5EF4-FFF2-40B4-BE49-F238E27FC236}">
-                <a16:creationId xmlns:a16="http://schemas.microsoft.com/office/drawing/2014/main" id="{148488F8-9F82-7BF9-483B-87B1C79980ED}"/>
-              </a:ext>
-            </a:extLst>
-          </p:cNvPr>
-          <p:cNvPicPr>
-            <a:picLocks noChangeAspect="1"/>
-          </p:cNvPicPr>
-          <p:nvPr/>
-        </p:nvPicPr>
-        <p:blipFill>
-          <a:blip r:embed="rId2"/>
-          <a:srcRect l="-749" t="38730" r="1"/>
-          <a:stretch>
-            <a:fillRect/>
-          </a:stretch>
-        </p:blipFill>
-        <p:spPr>
-          <a:xfrm>
-            <a:off x="5969498" y="1162813"/>
-            <a:ext cx="5687350" cy="5216111"/>
-          </a:xfrm>
-          <a:prstGeom prst="rect">
-            <a:avLst/>
-          </a:prstGeom>
-        </p:spPr>
-      </p:pic>
       <p:sp>
         <p:nvSpPr>
           <p:cNvPr id="2" name="Title 1">
@@ -11045,89 +11064,72 @@
           </a:p>
         </p:txBody>
       </p:sp>
-      <p:grpSp>
-        <p:nvGrpSpPr>
-          <p:cNvPr id="8" name="Group 7">
+      <p:sp>
+        <p:nvSpPr>
+          <p:cNvPr id="6" name="TextBox 5">
             <a:extLst>
               <a:ext uri="{FF2B5EF4-FFF2-40B4-BE49-F238E27FC236}">
-                <a16:creationId xmlns:a16="http://schemas.microsoft.com/office/drawing/2014/main" id="{49985504-5C9F-D548-4874-26E4024D2323}"/>
+                <a16:creationId xmlns:a16="http://schemas.microsoft.com/office/drawing/2014/main" id="{BE3E2614-C806-A67A-533B-7B038CC31F04}"/>
               </a:ext>
             </a:extLst>
           </p:cNvPr>
-          <p:cNvGrpSpPr/>
+          <p:cNvSpPr txBox="1"/>
           <p:nvPr/>
-        </p:nvGrpSpPr>
-        <p:grpSpPr>
+        </p:nvSpPr>
+        <p:spPr>
           <a:xfrm>
-            <a:off x="242390" y="2652584"/>
-            <a:ext cx="5687350" cy="3748481"/>
-            <a:chOff x="200024" y="2804186"/>
-            <a:chExt cx="5729716" cy="3595874"/>
+            <a:off x="5546361" y="1154242"/>
+            <a:ext cx="6317563" cy="369332"/>
           </a:xfrm>
-        </p:grpSpPr>
-        <p:pic>
-          <p:nvPicPr>
-            <p:cNvPr id="4" name="Picture 3">
-              <a:extLst>
-                <a:ext uri="{FF2B5EF4-FFF2-40B4-BE49-F238E27FC236}">
-                  <a16:creationId xmlns:a16="http://schemas.microsoft.com/office/drawing/2014/main" id="{BD0FF107-BFEA-2E82-3886-57B12846BA8A}"/>
-                </a:ext>
-              </a:extLst>
-            </p:cNvPr>
-            <p:cNvPicPr>
-              <a:picLocks noChangeAspect="1"/>
-            </p:cNvPicPr>
-            <p:nvPr/>
-          </p:nvPicPr>
-          <p:blipFill>
-            <a:blip r:embed="rId2"/>
-            <a:srcRect b="60706"/>
-            <a:stretch>
-              <a:fillRect/>
-            </a:stretch>
-          </p:blipFill>
-          <p:spPr>
-            <a:xfrm>
-              <a:off x="242389" y="2804186"/>
-              <a:ext cx="5687351" cy="3370269"/>
-            </a:xfrm>
-            <a:prstGeom prst="rect">
-              <a:avLst/>
-            </a:prstGeom>
-          </p:spPr>
-        </p:pic>
-        <p:pic>
-          <p:nvPicPr>
-            <p:cNvPr id="5" name="Picture 4">
-              <a:extLst>
-                <a:ext uri="{FF2B5EF4-FFF2-40B4-BE49-F238E27FC236}">
-                  <a16:creationId xmlns:a16="http://schemas.microsoft.com/office/drawing/2014/main" id="{4B8C4BF3-F205-B098-7104-34E13AEF07B7}"/>
-                </a:ext>
-              </a:extLst>
-            </p:cNvPr>
-            <p:cNvPicPr>
-              <a:picLocks noChangeAspect="1"/>
-            </p:cNvPicPr>
-            <p:nvPr/>
-          </p:nvPicPr>
-          <p:blipFill>
-            <a:blip r:embed="rId2"/>
-            <a:srcRect l="-749" t="96097" r="1"/>
-            <a:stretch>
-              <a:fillRect/>
-            </a:stretch>
-          </p:blipFill>
-          <p:spPr>
-            <a:xfrm>
-              <a:off x="200024" y="6066306"/>
-              <a:ext cx="5729715" cy="333754"/>
-            </a:xfrm>
-            <a:prstGeom prst="rect">
-              <a:avLst/>
-            </a:prstGeom>
-          </p:spPr>
-        </p:pic>
-      </p:grpSp>
+          <a:prstGeom prst="rect">
+            <a:avLst/>
+          </a:prstGeom>
+          <a:noFill/>
+        </p:spPr>
+        <p:txBody>
+          <a:bodyPr wrap="none" rtlCol="0">
+            <a:spAutoFit/>
+          </a:bodyPr>
+          <a:lstStyle/>
+          <a:p>
+            <a:r>
+              <a:rPr lang="en-US" i="1" dirty="0"/>
+              <a:t>Most sites significantly curtailed load during the June 14 event</a:t>
+            </a:r>
+            <a:endParaRPr lang="en-US" dirty="0"/>
+          </a:p>
+        </p:txBody>
+      </p:sp>
+      <p:pic>
+        <p:nvPicPr>
+          <p:cNvPr id="11" name="Picture 10">
+            <a:extLst>
+              <a:ext uri="{FF2B5EF4-FFF2-40B4-BE49-F238E27FC236}">
+                <a16:creationId xmlns:a16="http://schemas.microsoft.com/office/drawing/2014/main" id="{2A424C8F-F14D-BFF9-4CD9-9A512343A9F9}"/>
+              </a:ext>
+            </a:extLst>
+          </p:cNvPr>
+          <p:cNvPicPr>
+            <a:picLocks noChangeAspect="1"/>
+          </p:cNvPicPr>
+          <p:nvPr/>
+        </p:nvPicPr>
+        <p:blipFill>
+          <a:blip r:embed="rId2"/>
+          <a:stretch>
+            <a:fillRect/>
+          </a:stretch>
+        </p:blipFill>
+        <p:spPr>
+          <a:xfrm>
+            <a:off x="665189" y="1772176"/>
+            <a:ext cx="10861622" cy="4719470"/>
+          </a:xfrm>
+          <a:prstGeom prst="rect">
+            <a:avLst/>
+          </a:prstGeom>
+        </p:spPr>
+      </p:pic>
     </p:spTree>
     <p:extLst>
       <p:ext uri="{BB962C8B-B14F-4D97-AF65-F5344CB8AC3E}">
@@ -11187,13 +11189,13 @@
           <p:nvPr>
             <p:extLst>
               <p:ext uri="{D42A27DB-BD31-4B8C-83A1-F6EECF244321}">
-                <p14:modId xmlns:p14="http://schemas.microsoft.com/office/powerpoint/2010/main" val="743085911"/>
+                <p14:modId xmlns:p14="http://schemas.microsoft.com/office/powerpoint/2010/main" val="2689818224"/>
               </p:ext>
             </p:extLst>
           </p:nvPr>
         </p:nvGraphicFramePr>
         <p:xfrm>
-          <a:off x="820893" y="2136586"/>
+          <a:off x="933577" y="1751576"/>
           <a:ext cx="4368634" cy="2825159"/>
         </p:xfrm>
         <a:graphic>
@@ -12524,6 +12526,14 @@
                         <a:rPr lang="en-US" sz="1800" dirty="0"/>
                         <a:t>-12</a:t>
                       </a:r>
+                      <a:r>
+                        <a:rPr lang="en-US" sz="1800" dirty="0">
+                          <a:solidFill>
+                            <a:srgbClr val="FF0000"/>
+                          </a:solidFill>
+                        </a:rPr>
+                        <a:t>*</a:t>
+                      </a:r>
                     </a:p>
                   </a:txBody>
                   <a:tcPr anchor="ctr">
@@ -12728,7 +12738,7 @@
         </p:nvSpPr>
         <p:spPr bwMode="auto">
           <a:xfrm>
-            <a:off x="820893" y="5261124"/>
+            <a:off x="827269" y="5054600"/>
             <a:ext cx="9780717" cy="1200329"/>
           </a:xfrm>
           <a:prstGeom prst="rect">
@@ -12804,6 +12814,37 @@
                 <a:effectLst/>
                 <a:latin typeface="Bierstadt" panose="020B0004020202020204" pitchFamily="34" charset="0"/>
               </a:rPr>
+              <a:t>Performance = Baseline – Actual, averaged over event hours</a:t>
+            </a:r>
+          </a:p>
+          <a:p>
+            <a:pPr marL="285750" marR="0" lvl="0" indent="-285750" algn="l" defTabSz="914400" rtl="0" eaLnBrk="0" fontAlgn="base" latinLnBrk="0" hangingPunct="0">
+              <a:lnSpc>
+                <a:spcPct val="100000"/>
+              </a:lnSpc>
+              <a:spcBef>
+                <a:spcPct val="0"/>
+              </a:spcBef>
+              <a:spcAft>
+                <a:spcPct val="0"/>
+              </a:spcAft>
+              <a:buClrTx/>
+              <a:buSzTx/>
+              <a:buFont typeface="Arial" panose="020B0604020202020204" pitchFamily="34" charset="0"/>
+              <a:buChar char="•"/>
+              <a:tabLst/>
+            </a:pPr>
+            <a:r>
+              <a:rPr kumimoji="0" lang="en-US" altLang="en-US" sz="1800" b="0" i="0" u="none" strike="noStrike" cap="none" normalizeH="0" baseline="0" dirty="0">
+                <a:ln>
+                  <a:noFill/>
+                </a:ln>
+                <a:solidFill>
+                  <a:schemeClr val="tx1"/>
+                </a:solidFill>
+                <a:effectLst/>
+                <a:latin typeface="Bierstadt" panose="020B0004020202020204" pitchFamily="34" charset="0"/>
+              </a:rPr>
               <a:t>Baseline methodology affects performance</a:t>
             </a:r>
             <a:r>
@@ -12851,23 +12892,11 @@
                 <a:effectLst/>
                 <a:latin typeface="Bierstadt" panose="020B0004020202020204" pitchFamily="34" charset="0"/>
               </a:rPr>
-              <a:t>Different operational pattern benefit from different baselines:</a:t>
+              <a:t>Different operational pattern benefit from different baselines: </a:t>
             </a:r>
-          </a:p>
-          <a:p>
-            <a:pPr marL="742950" lvl="1" indent="-285750" eaLnBrk="0" fontAlgn="base" hangingPunct="0">
-              <a:spcBef>
-                <a:spcPct val="0"/>
-              </a:spcBef>
-              <a:spcAft>
-                <a:spcPct val="0"/>
-              </a:spcAft>
-              <a:buFont typeface="Arial" panose="020B0604020202020204" pitchFamily="34" charset="0"/>
-              <a:buChar char="•"/>
-            </a:pPr>
             <a:r>
               <a:rPr lang="en-US" dirty="0"/>
-              <a:t>If the customer has been recently using high load, then the 10of10 baseline would increase, making their event reduction look larger. </a:t>
+              <a:t>if recent load was elevated, baseline rises, which can increase measured curtailment during the event.</a:t>
             </a:r>
           </a:p>
         </p:txBody>
@@ -12943,13 +12972,13 @@
           <p:nvPr>
             <p:extLst>
               <p:ext uri="{D42A27DB-BD31-4B8C-83A1-F6EECF244321}">
-                <p14:modId xmlns:p14="http://schemas.microsoft.com/office/powerpoint/2010/main" val="1982626781"/>
+                <p14:modId xmlns:p14="http://schemas.microsoft.com/office/powerpoint/2010/main" val="1652453538"/>
               </p:ext>
             </p:extLst>
           </p:nvPr>
         </p:nvGraphicFramePr>
         <p:xfrm>
-          <a:off x="5717627" y="1576552"/>
+          <a:off x="5717628" y="1405066"/>
           <a:ext cx="5653479" cy="3547241"/>
         </p:xfrm>
         <a:graphic>
@@ -12958,6 +12987,45 @@
           </a:graphicData>
         </a:graphic>
       </p:graphicFrame>
+      <p:sp>
+        <p:nvSpPr>
+          <p:cNvPr id="2" name="TextBox 1">
+            <a:extLst>
+              <a:ext uri="{FF2B5EF4-FFF2-40B4-BE49-F238E27FC236}">
+                <a16:creationId xmlns:a16="http://schemas.microsoft.com/office/drawing/2014/main" id="{45E316A2-0AA2-5295-ACB1-5D8A3FFB9A11}"/>
+              </a:ext>
+            </a:extLst>
+          </p:cNvPr>
+          <p:cNvSpPr txBox="1"/>
+          <p:nvPr/>
+        </p:nvSpPr>
+        <p:spPr>
+          <a:xfrm>
+            <a:off x="518160" y="6357222"/>
+            <a:ext cx="6247223" cy="261610"/>
+          </a:xfrm>
+          <a:prstGeom prst="rect">
+            <a:avLst/>
+          </a:prstGeom>
+          <a:noFill/>
+        </p:spPr>
+        <p:txBody>
+          <a:bodyPr wrap="none" rtlCol="0">
+            <a:spAutoFit/>
+          </a:bodyPr>
+          <a:lstStyle/>
+          <a:p>
+            <a:r>
+              <a:rPr lang="en-US" sz="1100" dirty="0">
+                <a:solidFill>
+                  <a:schemeClr val="accent3"/>
+                </a:solidFill>
+              </a:rPr>
+              <a:t>* Negative performance indicates load above baseline. Treated as 0 for payout calculations per hour.</a:t>
+            </a:r>
+          </a:p>
+        </p:txBody>
+      </p:sp>
     </p:spTree>
     <p:extLst>
       <p:ext uri="{BB962C8B-B14F-4D97-AF65-F5344CB8AC3E}">
@@ -13017,7 +13085,7 @@
           <p:nvPr>
             <p:extLst>
               <p:ext uri="{D42A27DB-BD31-4B8C-83A1-F6EECF244321}">
-                <p14:modId xmlns:p14="http://schemas.microsoft.com/office/powerpoint/2010/main" val="1060221927"/>
+                <p14:modId xmlns:p14="http://schemas.microsoft.com/office/powerpoint/2010/main" val="1476816967"/>
               </p:ext>
             </p:extLst>
           </p:nvPr>
@@ -14377,7 +14445,7 @@
                         <a:buNone/>
                       </a:pPr>
                       <a:r>
-                        <a:rPr lang="en-US" sz="1800" b="0" i="0" u="none" strike="noStrike">
+                        <a:rPr lang="en-US" sz="1800" b="0" i="0" u="none" strike="noStrike" dirty="0">
                           <a:solidFill>
                             <a:srgbClr val="000000"/>
                           </a:solidFill>
@@ -14385,6 +14453,16 @@
                           <a:latin typeface="Bierstadt" panose="020B0004020202020204" pitchFamily="34" charset="0"/>
                         </a:rPr>
                         <a:t>Site 6</a:t>
+                      </a:r>
+                      <a:r>
+                        <a:rPr lang="en-US" sz="1800" b="0" i="0" u="none" strike="noStrike" dirty="0">
+                          <a:solidFill>
+                            <a:schemeClr val="accent3"/>
+                          </a:solidFill>
+                          <a:effectLst/>
+                          <a:latin typeface="Bierstadt" panose="020B0004020202020204" pitchFamily="34" charset="0"/>
+                        </a:rPr>
+                        <a:t>*</a:t>
                       </a:r>
                     </a:p>
                   </a:txBody>
@@ -14796,7 +14874,7 @@
                       <a:r>
                         <a:rPr lang="en-US" sz="1800" b="0" i="0" u="none" strike="noStrike" dirty="0">
                           <a:solidFill>
-                            <a:srgbClr val="000000"/>
+                            <a:srgbClr val="C00000"/>
                           </a:solidFill>
                           <a:effectLst/>
                           <a:latin typeface="Bierstadt" panose="020B0004020202020204" pitchFamily="34" charset="0"/>
@@ -14857,8 +14935,8 @@
         </p:nvSpPr>
         <p:spPr bwMode="auto">
           <a:xfrm>
-            <a:off x="887433" y="5629194"/>
-            <a:ext cx="5602514" cy="646331"/>
+            <a:off x="887433" y="5490695"/>
+            <a:ext cx="7233310" cy="923330"/>
           </a:xfrm>
           <a:prstGeom prst="rect">
             <a:avLst/>
@@ -14933,39 +15011,49 @@
                 <a:effectLst/>
                 <a:latin typeface="Bierstadt" panose="020B0004020202020204" pitchFamily="34" charset="0"/>
               </a:rPr>
-              <a:t>Revenue concentrated in Sites 1, 2, and 5.</a:t>
+              <a:t>Computed using the 10of10 </a:t>
+            </a:r>
+            <a:r>
+              <a:rPr lang="en-US" altLang="en-US" dirty="0">
+                <a:latin typeface="Bierstadt" panose="020B0004020202020204" pitchFamily="34" charset="0"/>
+              </a:rPr>
+              <a:t>baseline and performance. </a:t>
             </a:r>
           </a:p>
           <a:p>
-            <a:pPr marL="285750" marR="0" lvl="0" indent="-285750" algn="l" defTabSz="914400" rtl="0" eaLnBrk="0" fontAlgn="base" latinLnBrk="0" hangingPunct="0">
-              <a:lnSpc>
-                <a:spcPct val="100000"/>
-              </a:lnSpc>
+            <a:pPr marL="285750" lvl="0" indent="-285750" eaLnBrk="0" fontAlgn="base" hangingPunct="0">
               <a:spcBef>
                 <a:spcPct val="0"/>
               </a:spcBef>
               <a:spcAft>
                 <a:spcPct val="0"/>
               </a:spcAft>
-              <a:buClrTx/>
-              <a:buSzTx/>
               <a:buFont typeface="Arial" panose="020B0604020202020204" pitchFamily="34" charset="0"/>
               <a:buChar char="•"/>
-              <a:tabLst/>
             </a:pPr>
             <a:r>
-              <a:rPr kumimoji="0" lang="en-US" altLang="en-US" sz="1800" b="0" i="0" u="none" strike="noStrike" cap="none" normalizeH="0" baseline="0" dirty="0">
-                <a:ln>
-                  <a:noFill/>
-                </a:ln>
-                <a:solidFill>
-                  <a:schemeClr val="tx1"/>
-                </a:solidFill>
-                <a:effectLst/>
-                <a:latin typeface="Bierstadt" panose="020B0004020202020204" pitchFamily="34" charset="0"/>
-              </a:rPr>
-              <a:t>Assumption: negative performance floored at 0.</a:t>
+              <a:rPr lang="en-US" dirty="0"/>
+              <a:t>Total portfolio profit: $30.8K across 5 sites.</a:t>
             </a:r>
+          </a:p>
+          <a:p>
+            <a:pPr marL="285750" lvl="0" indent="-285750" eaLnBrk="0" fontAlgn="base" hangingPunct="0">
+              <a:spcBef>
+                <a:spcPct val="0"/>
+              </a:spcBef>
+              <a:spcAft>
+                <a:spcPct val="0"/>
+              </a:spcAft>
+              <a:buFont typeface="Arial" panose="020B0604020202020204" pitchFamily="34" charset="0"/>
+              <a:buChar char="•"/>
+            </a:pPr>
+            <a:r>
+              <a:rPr lang="en-US" dirty="0"/>
+              <a:t>Sites 1, 2, and 5 drive ~95% of total profit.</a:t>
+            </a:r>
+            <a:endParaRPr lang="en-US" altLang="en-US" dirty="0">
+              <a:latin typeface="Bierstadt" panose="020B0004020202020204" pitchFamily="34" charset="0"/>
+            </a:endParaRPr>
           </a:p>
         </p:txBody>
       </p:sp>
@@ -15200,7 +15288,7 @@
         <p:spPr>
           <a:xfrm>
             <a:off x="7305253" y="4027389"/>
-            <a:ext cx="3880907" cy="1477328"/>
+            <a:ext cx="3390821" cy="1323439"/>
           </a:xfrm>
           <a:prstGeom prst="rect">
             <a:avLst/>
@@ -15216,13 +15304,13 @@
           <a:lstStyle/>
           <a:p>
             <a:r>
-              <a:rPr lang="en-US" b="0" i="0" dirty="0">
+              <a:rPr lang="en-US" sz="1600" b="0" i="0" dirty="0">
                 <a:effectLst/>
                 <a:latin typeface="Bierstadt" panose="020B0004020202020204" pitchFamily="34" charset="0"/>
               </a:rPr>
               <a:t>Site 2 was the strongest performer. Event load dropped to ~320 kW against a ~4,700 kW baseline, meaning it curtailed over 90% of its normal usage. </a:t>
             </a:r>
-            <a:endParaRPr lang="en-US" dirty="0">
+            <a:endParaRPr lang="en-US" sz="1600" dirty="0">
               <a:latin typeface="Bierstadt" panose="020B0004020202020204" pitchFamily="34" charset="0"/>
             </a:endParaRPr>
           </a:p>
@@ -15287,7 +15375,7 @@
           <p:nvPr>
             <p:extLst>
               <p:ext uri="{D42A27DB-BD31-4B8C-83A1-F6EECF244321}">
-                <p14:modId xmlns:p14="http://schemas.microsoft.com/office/powerpoint/2010/main" val="2693719434"/>
+                <p14:modId xmlns:p14="http://schemas.microsoft.com/office/powerpoint/2010/main" val="4120269217"/>
               </p:ext>
             </p:extLst>
           </p:nvPr>
@@ -15414,7 +15502,7 @@
                           <a:effectLst/>
                           <a:latin typeface="Bierstadt" panose="020B0004020202020204" pitchFamily="34" charset="0"/>
                         </a:rPr>
-                        <a:t>Load (kw)</a:t>
+                        <a:t>Load (kW)</a:t>
                       </a:r>
                     </a:p>
                   </a:txBody>

</xml_diff>